<commit_message>
docs: year-end report - deployment status (RCS account + firewall done, headless test), SKEWNONO alarm reuse, final goal; spell out CV
Co-Authored-By: Claude Opus 5.5 <noreply@anthropic.com>
</commit_message>
<xml_diff>
--- a/docs/project_progress/Align_Tuning_Agent_2026_year_end.pptx
+++ b/docs/project_progress/Align_Tuning_Agent_2026_year_end.pptx
@@ -4013,7 +4013,7 @@
         </p:nvGraphicFramePr>
         <p:xfrm>
           <a:off x="571500" y="2762250"/>
-          <a:ext cx="11049000" cy="3657600"/>
+          <a:ext cx="11049000" cy="3600450"/>
         </p:xfrm>
         <a:graphic>
           <a:graphicData uri="http://schemas.openxmlformats.org/drawingml/2006/table">
@@ -4026,7 +4026,7 @@
                 <a:gridCol w="1428750"/>
                 <a:gridCol w="7239000"/>
               </a:tblGrid>
-              <a:tr h="609600">
+              <a:tr h="514350">
                 <a:tc>
                   <a:txBody>
                     <a:bodyPr wrap="square"/>
@@ -4100,7 +4100,7 @@
                   </a:tcPr>
                 </a:tc>
               </a:tr>
-              <a:tr h="609600">
+              <a:tr h="514350">
                 <a:tc>
                   <a:txBody>
                     <a:bodyPr wrap="square"/>
@@ -4174,7 +4174,7 @@
                   </a:tcPr>
                 </a:tc>
               </a:tr>
-              <a:tr h="609600">
+              <a:tr h="514350">
                 <a:tc>
                   <a:txBody>
                     <a:bodyPr wrap="square"/>
@@ -4248,7 +4248,7 @@
                   </a:tcPr>
                 </a:tc>
               </a:tr>
-              <a:tr h="609600">
+              <a:tr h="514350">
                 <a:tc>
                   <a:txBody>
                     <a:bodyPr wrap="square"/>
@@ -4322,7 +4322,7 @@
                   </a:tcPr>
                 </a:tc>
               </a:tr>
-              <a:tr h="609600">
+              <a:tr h="514350">
                 <a:tc>
                   <a:txBody>
                     <a:bodyPr wrap="square"/>
@@ -4396,7 +4396,7 @@
                   </a:tcPr>
                 </a:tc>
               </a:tr>
-              <a:tr h="609600">
+              <a:tr h="514350">
                 <a:tc>
                   <a:txBody>
                     <a:bodyPr wrap="square"/>
@@ -4411,7 +4411,7 @@
                           <a:ea typeface="맑은 고딕"/>
                           <a:cs typeface="맑은 고딕"/>
                         </a:rPr>
-                        <a:t>R3 26대 실전 배치</a:t>
+                        <a:t>알람 감지 확산</a:t>
                       </a:r>
                     </a:p>
                   </a:txBody>
@@ -4435,7 +4435,7 @@
                           <a:ea typeface="맑은 고딕"/>
                           <a:cs typeface="맑은 고딕"/>
                         </a:rPr>
-                        <a:t>준비 중</a:t>
+                        <a:t>활용 중</a:t>
                       </a:r>
                     </a:p>
                   </a:txBody>
@@ -4459,13 +4459,87 @@
                           <a:ea typeface="맑은 고딕"/>
                           <a:cs typeface="맑은 고딕"/>
                         </a:rPr>
-                        <a:t>상시 운영 PC, IP 방화벽 해제, AI 전용 RCS 계정 발행 진행</a:t>
+                        <a:t>같은 알람 감지를 스큐노노 실시간 알람에 적용, 인라인 교대 구성원이 실시간 대응에 활용</a:t>
                       </a:r>
                     </a:p>
                   </a:txBody>
                   <a:tcPr marL="95250" marR="95250">
                     <a:solidFill>
                       <a:srgbClr val="FBF8F3"/>
+                    </a:solidFill>
+                  </a:tcPr>
+                </a:tc>
+              </a:tr>
+              <a:tr h="514350">
+                <a:tc>
+                  <a:txBody>
+                    <a:bodyPr wrap="square"/>
+                    <a:lstStyle/>
+                    <a:p>
+                      <a:r>
+                        <a:rPr sz="1300" b="1">
+                          <a:solidFill>
+                            <a:srgbClr val="15110D"/>
+                          </a:solidFill>
+                          <a:latin typeface="맑은 고딕"/>
+                          <a:ea typeface="맑은 고딕"/>
+                          <a:cs typeface="맑은 고딕"/>
+                        </a:rPr>
+                        <a:t>R3 26대 실전 배치</a:t>
+                      </a:r>
+                    </a:p>
+                  </a:txBody>
+                  <a:tcPr marL="95250" marR="95250">
+                    <a:solidFill>
+                      <a:srgbClr val="F4EFE8"/>
+                    </a:solidFill>
+                  </a:tcPr>
+                </a:tc>
+                <a:tc>
+                  <a:txBody>
+                    <a:bodyPr wrap="square"/>
+                    <a:lstStyle/>
+                    <a:p>
+                      <a:r>
+                        <a:rPr sz="1300" b="0">
+                          <a:solidFill>
+                            <a:srgbClr val="15110D"/>
+                          </a:solidFill>
+                          <a:latin typeface="맑은 고딕"/>
+                          <a:ea typeface="맑은 고딕"/>
+                          <a:cs typeface="맑은 고딕"/>
+                        </a:rPr>
+                        <a:t>준비 중</a:t>
+                      </a:r>
+                    </a:p>
+                  </a:txBody>
+                  <a:tcPr marL="95250" marR="95250">
+                    <a:solidFill>
+                      <a:srgbClr val="F4EFE8"/>
+                    </a:solidFill>
+                  </a:tcPr>
+                </a:tc>
+                <a:tc>
+                  <a:txBody>
+                    <a:bodyPr wrap="square"/>
+                    <a:lstStyle/>
+                    <a:p>
+                      <a:r>
+                        <a:rPr sz="1300" b="0">
+                          <a:solidFill>
+                            <a:srgbClr val="15110D"/>
+                          </a:solidFill>
+                          <a:latin typeface="맑은 고딕"/>
+                          <a:ea typeface="맑은 고딕"/>
+                          <a:cs typeface="맑은 고딕"/>
+                        </a:rPr>
+                        <a:t>AI 전용 RCS 계정 발행 · IP 방화벽 해제 완료, Headless 제어 가능성 테스트 중</a:t>
+                      </a:r>
+                    </a:p>
+                  </a:txBody>
+                  <a:tcPr marL="95250" marR="95250">
+                    <a:solidFill>
+                      <a:srgbClr val="F4EFE8"/>
                     </a:solidFill>
                   </a:tcPr>
                 </a:tc>
@@ -5129,7 +5203,7 @@
                 <a:ea typeface="맑은 고딕"/>
                 <a:cs typeface="맑은 고딕"/>
               </a:rPr>
-              <a:t>• CV 가 좌표를 정하고 OK 까지 누름</a:t>
+              <a:t>• CV(Computer Vision, 이미지 매칭)가 좌표를 정하고 OK 까지 누름</a:t>
             </a:r>
           </a:p>
           <a:p>
@@ -7982,7 +8056,7 @@
                 <a:ea typeface="맑은 고딕"/>
                 <a:cs typeface="맑은 고딕"/>
               </a:rPr>
-              <a:t>• [진행 중] reverse engineering 으로 RCS 화면 없이(headless) 장비 제어 -&gt; GUI 자동화처럼 Agent 가 PC 를 점유하지 않아, 가동 중에도 엔지니어가 다른 작업 병행</a:t>
+              <a:t>• [테스트 중] reverse engineering 으로 RCS 화면 없이(headless) 장비 제어 -&gt; GUI 자동화처럼 Agent 가 PC 를 점유하지 않아, 가동 중에도 엔지니어가 다른 작업 병행</a:t>
             </a:r>
           </a:p>
           <a:p>
@@ -8000,7 +8074,7 @@
                 <a:ea typeface="맑은 고딕"/>
                 <a:cs typeface="맑은 고딕"/>
               </a:rPr>
-              <a:t>• 상시 운영 PC · 방화벽 · AI 전용 계정 마무리 -&gt; 단일 장비 pilot -&gt; R3 26대 확대</a:t>
+              <a:t>• AI 전용 계정 · 방화벽 완료, 상시 운영 PC 마무리 -&gt; 단일 장비 pilot -&gt; R3 26대 확대</a:t>
             </a:r>
           </a:p>
           <a:p>
@@ -8055,6 +8129,47 @@
                 <a:cs typeface="맑은 고딕"/>
               </a:rPr>
               <a:t>• 2027년: VLM 이 Recipe Tuning 을 직접 수행하도록 확장</a:t>
+            </a:r>
+          </a:p>
+        </p:txBody>
+      </p:sp>
+      <p:sp>
+        <p:nvSpPr>
+          <p:cNvPr id="18" name="TextBox 17"/>
+          <p:cNvSpPr txBox="1"/>
+          <p:nvPr/>
+        </p:nvSpPr>
+        <p:spPr>
+          <a:xfrm>
+            <a:off x="571500" y="6096000"/>
+            <a:ext cx="11049000" cy="381000"/>
+          </a:xfrm>
+          <a:prstGeom prst="rect">
+            <a:avLst/>
+          </a:prstGeom>
+          <a:noFill/>
+        </p:spPr>
+        <p:txBody>
+          <a:bodyPr wrap="square" anchor="t" lIns="38100" rIns="38100">
+            <a:spAutoFit/>
+          </a:bodyPr>
+          <a:lstStyle/>
+          <a:p>
+            <a:pPr>
+              <a:spcAft>
+                <a:spcPts val="400"/>
+              </a:spcAft>
+            </a:pPr>
+            <a:r>
+              <a:rPr sz="1800" b="1">
+                <a:solidFill>
+                  <a:srgbClr val="C75A3C"/>
+                </a:solidFill>
+                <a:latin typeface="맑은 고딕"/>
+                <a:ea typeface="맑은 고딕"/>
+                <a:cs typeface="맑은 고딕"/>
+              </a:rPr>
+              <a:t>최종 목표 · 교대조의 Align Fail 대응을 Agent 가 대신 진행</a:t>
             </a:r>
           </a:p>
         </p:txBody>

</xml_diff>

<commit_message>
docs: year-end report title Align Tuning Agent -> Align Fail 자동 대응 Agent (cover title split into two lines)
Co-Authored-By: Claude Opus 5.5 <noreply@anthropic.com>
</commit_message>
<xml_diff>
--- a/docs/project_progress/Align_Tuning_Agent_2026_year_end.pptx
+++ b/docs/project_progress/Align_Tuning_Agent_2026_year_end.pptx
@@ -3385,7 +3385,7 @@
                 <a:ea typeface="맑은 고딕"/>
                 <a:cs typeface="맑은 고딕"/>
               </a:rPr>
-              <a:t>ALIGN TUNING AGENT · 2026-10-21</a:t>
+              <a:t>ALIGN FAIL 자동 대응 AGENT · 2026-10-21</a:t>
             </a:r>
           </a:p>
         </p:txBody>
@@ -3399,7 +3399,7 @@
         <p:spPr>
           <a:xfrm>
             <a:off x="762000" y="2381250"/>
-            <a:ext cx="10477500" cy="762000"/>
+            <a:ext cx="10477500" cy="1333500"/>
           </a:xfrm>
           <a:prstGeom prst="rect">
             <a:avLst/>
@@ -3426,7 +3426,25 @@
                 <a:ea typeface="맑은 고딕"/>
                 <a:cs typeface="맑은 고딕"/>
               </a:rPr>
-              <a:t>Align Tuning Agent 2026년 성과 보고</a:t>
+              <a:t>Align Fail 자동 대응 Agent</a:t>
+            </a:r>
+          </a:p>
+          <a:p>
+            <a:pPr>
+              <a:spcAft>
+                <a:spcPts val="400"/>
+              </a:spcAft>
+            </a:pPr>
+            <a:r>
+              <a:rPr sz="4000" b="1">
+                <a:solidFill>
+                  <a:srgbClr val="F8F4EC"/>
+                </a:solidFill>
+                <a:latin typeface="맑은 고딕"/>
+                <a:ea typeface="맑은 고딕"/>
+                <a:cs typeface="맑은 고딕"/>
+              </a:rPr>
+              <a:t>2026년 성과 보고</a:t>
             </a:r>
           </a:p>
         </p:txBody>
@@ -3439,7 +3457,7 @@
         </p:nvSpPr>
         <p:spPr>
           <a:xfrm>
-            <a:off x="762000" y="3333750"/>
+            <a:off x="762000" y="3905250"/>
             <a:ext cx="9525000" cy="857250"/>
           </a:xfrm>
           <a:prstGeom prst="rect">
@@ -3526,7 +3544,7 @@
                 <a:ea typeface="맑은 고딕"/>
                 <a:cs typeface="맑은 고딕"/>
               </a:rPr>
-              <a:t>ALIGN TUNING AGENT · 2026 성과 보고 · 01</a:t>
+              <a:t>ALIGN FAIL 자동 대응 AGENT · 2026 성과 보고 · 01</a:t>
             </a:r>
           </a:p>
         </p:txBody>
@@ -4602,7 +4620,7 @@
                 <a:ea typeface="맑은 고딕"/>
                 <a:cs typeface="맑은 고딕"/>
               </a:rPr>
-              <a:t>ALIGN TUNING AGENT · 2026 성과 보고 · 02</a:t>
+              <a:t>ALIGN FAIL 자동 대응 AGENT · 2026 성과 보고 · 02</a:t>
             </a:r>
           </a:p>
         </p:txBody>
@@ -5339,7 +5357,7 @@
                 <a:ea typeface="맑은 고딕"/>
                 <a:cs typeface="맑은 고딕"/>
               </a:rPr>
-              <a:t>ALIGN TUNING AGENT · 2026 성과 보고 · 03</a:t>
+              <a:t>ALIGN FAIL 자동 대응 AGENT · 2026 성과 보고 · 03</a:t>
             </a:r>
           </a:p>
         </p:txBody>
@@ -6302,7 +6320,7 @@
                 <a:ea typeface="맑은 고딕"/>
                 <a:cs typeface="맑은 고딕"/>
               </a:rPr>
-              <a:t>ALIGN TUNING AGENT · 2026 성과 보고 · 04</a:t>
+              <a:t>ALIGN FAIL 자동 대응 AGENT · 2026 성과 보고 · 04</a:t>
             </a:r>
           </a:p>
         </p:txBody>
@@ -6709,7 +6727,7 @@
                 <a:ea typeface="맑은 고딕"/>
                 <a:cs typeface="맑은 고딕"/>
               </a:rPr>
-              <a:t>ALIGN TUNING AGENT · 2026 성과 보고 · 05</a:t>
+              <a:t>ALIGN FAIL 자동 대응 AGENT · 2026 성과 보고 · 05</a:t>
             </a:r>
           </a:p>
         </p:txBody>
@@ -7178,7 +7196,7 @@
                 <a:ea typeface="맑은 고딕"/>
                 <a:cs typeface="맑은 고딕"/>
               </a:rPr>
-              <a:t>ALIGN TUNING AGENT · 2026 성과 보고 · 06</a:t>
+              <a:t>ALIGN FAIL 자동 대응 AGENT · 2026 성과 보고 · 06</a:t>
             </a:r>
           </a:p>
         </p:txBody>

</xml_diff>